<commit_message>
lectures: add AWS deck and its build script
Add slidesAWS.md (92 slides) with PDF and PPTX outputs, plus
buildAWS.sh — a TOPOS-style one-line wrapper over the parameterized
build.sh.

Also picks up the latest slidesTOPOS.md edits and its rebuilt outputs.

Co-Authored-By: Claude Opus 5 (1M context) <noreply@anthropic.com>
</commit_message>
<xml_diff>
--- a/lectures/slidesTOPOS.pptx
+++ b/lectures/slidesTOPOS.pptx
@@ -3528,7 +3528,7 @@
             </a:pPr>
             <a:r>
               <a:rPr lang="en-US" sz="3200"/>
-              <a:t>APAS-AI - AI Paired Programming APAS in Rust</a:t>
+              <a:t>APAS-AI - AI Programming APAS in Rust</a:t>
             </a:r>
           </a:p>
         </p:txBody>
@@ -3719,13 +3719,6 @@
             <a:pPr lvl="1"/>
             <a:r>
               <a:rPr lang="en-US" sz="1800"/>
-              <a:t>1.2× the source code size which is heavy.</a:t>
-            </a:r>
-          </a:p>
-          <a:p>
-            <a:pPr lvl="1"/>
-            <a:r>
-              <a:rPr lang="en-US" sz="1800"/>
               <a:t>Tests are now so cheap and automated, I generally don’t count them.</a:t>
             </a:r>
           </a:p>
@@ -4008,7 +4001,7 @@
             <a:pPr lvl="0"/>
             <a:r>
               <a:rPr lang="en-US" sz="1800"/>
-              <a:t>spec functions, forall/exists, arithmetic, sets, sequences.</a:t>
+              <a:t>Spec functions, forall/exists, arithmetic, sets, sequences.</a:t>
             </a:r>
           </a:p>
           <a:p>
@@ -4036,7 +4029,7 @@
             <a:pPr lvl="0"/>
             <a:r>
               <a:rPr lang="en-US" sz="1800"/>
-              <a:t>Wraps existing Rust code: - spec / proof / requires / ensures on fns</a:t>
+              <a:t>Wraps existing Rust code: spec / proof / requires / ensures on fns</a:t>
             </a:r>
           </a:p>
           <a:p>
@@ -4128,7 +4121,14 @@
             <a:pPr lvl="0"/>
             <a:r>
               <a:rPr lang="en-US" sz="1800"/>
-              <a:t>A View maps an executable Rust type to a mathematical ghost type: “Vec views as Seq”, “HashSet views as Set”.</a:t>
+              <a:t>A View maps an executable Rust type to a math ghost type:</a:t>
+            </a:r>
+          </a:p>
+          <a:p>
+            <a:pPr lvl="1"/>
+            <a:r>
+              <a:rPr lang="en-US" sz="1800"/>
+              <a:t>“Vec views as Seq”, “HashSet views as Set”.</a:t>
             </a:r>
           </a:p>
           <a:p>
@@ -4142,14 +4142,21 @@
             <a:pPr lvl="0"/>
             <a:r>
               <a:rPr lang="en-US" sz="1800"/>
-              <a:t>vstd is Verus’s standard library — specs for Vec, Seq, Set, Map, Multiset, arithmetic, common lemmas, Fns …</a:t>
-            </a:r>
-          </a:p>
-          <a:p>
-            <a:pPr lvl="0"/>
-            <a:r>
-              <a:rPr lang="en-US" sz="1800"/>
-              <a:t>Ghost types live only in the verifier — they have no runtime cost and no runtime representation.</a:t>
+              <a:t>vstd is Verus’s standard library — specs for Vec, Seq, Set,</a:t>
+            </a:r>
+          </a:p>
+          <a:p>
+            <a:pPr lvl="1"/>
+            <a:r>
+              <a:rPr lang="en-US" sz="1800"/>
+              <a:t>Map, Multiset, arithmetic, common lemmas, Fns …</a:t>
+            </a:r>
+          </a:p>
+          <a:p>
+            <a:pPr lvl="0"/>
+            <a:r>
+              <a:rPr lang="en-US" sz="1800"/>
+              <a:t>Ghost types live only in the verifier</a:t>
             </a:r>
           </a:p>
         </p:txBody>
@@ -6208,13 +6215,6 @@
             <a:pPr lvl="0"/>
             <a:r>
               <a:rPr lang="en-US" sz="1800"/>
-              <a:t>Rusticate - sending Python back to the family estate</a:t>
-            </a:r>
-          </a:p>
-          <a:p>
-            <a:pPr lvl="0"/>
-            <a:r>
-              <a:rPr lang="en-US" sz="1800"/>
               <a:t>Verus - Proving Rust</a:t>
             </a:r>
           </a:p>
@@ -6261,18 +6261,8 @@
               <a:buNone/>
             </a:pPr>
             <a:r>
-              <a:rPr lang="en-US" sz="1100"/>
-              <a:t>UnDirGraphStEph — Impl: </a:t>
-            </a:r>
-            <a:r>
-              <a:rPr>
-                <a:latin typeface="Courier"/>
-              </a:rPr>
-              <a:t>neighborhood</a:t>
-            </a:r>
-            <a:r>
               <a:rPr lang="en-US" sz="3200"/>
-              <a:t> exec body</a:t>
+              <a:t>UnDirGraphStEph — Impl:</a:t>
             </a:r>
           </a:p>
         </p:txBody>
@@ -8116,7 +8106,7 @@
             </a:pPr>
             <a:r>
               <a:rPr lang="en-US" sz="3200"/>
-              <a:t>Wrapping Rust — Declaring an external function/method</a:t>
+              <a:t>Wrapping Rust — Declaring an external fun</a:t>
             </a:r>
           </a:p>
         </p:txBody>
@@ -8750,6 +8740,7 @@
             <a:pPr lvl="0" indent="0">
               <a:buNone/>
             </a:pPr>
+            <a:br/>
             <a:r>
               <a:rPr>
                 <a:solidFill>
@@ -8785,6 +8776,12 @@
             </a:r>
             <a:br/>
             <a:r>
+              <a:rPr lang="en-US" sz="1100">
+                <a:latin typeface="Courier"/>
+              </a:rPr>
+              <a:t>  </a:t>
+            </a:r>
+            <a:r>
               <a:rPr lang="en-US" sz="1100" b="1">
                 <a:solidFill>
                   <a:srgbClr val="007020"/>
@@ -8858,7 +8855,7 @@
               <a:rPr lang="en-US" sz="1100">
                 <a:latin typeface="Courier"/>
               </a:rPr>
-              <a:t>    </a:t>
+              <a:t>      </a:t>
             </a:r>
             <a:r>
               <a:rPr lang="en-US" sz="1100" b="1">
@@ -8889,7 +8886,7 @@
               <a:rPr lang="en-US" sz="1100">
                 <a:latin typeface="Courier"/>
               </a:rPr>
-              <a:t>    </a:t>
+              <a:t>      </a:t>
             </a:r>
             <a:r>
               <a:rPr lang="en-US" sz="1100" b="1">
@@ -8964,6 +8961,12 @@
               <a:t>;</a:t>
             </a:r>
             <a:br/>
+            <a:r>
+              <a:rPr lang="en-US" sz="1100">
+                <a:latin typeface="Courier"/>
+              </a:rPr>
+              <a:t>  </a:t>
+            </a:r>
             <a:r>
               <a:rPr lang="en-US" sz="1100">
                 <a:solidFill>
@@ -9015,7 +9018,7 @@
             </a:r>
             <a:r>
               <a:rPr lang="en-US" sz="1800"/>
-              <a:t> to the method to give it a full contract.</a:t>
+              <a:t> to the method to give it a full spec.</a:t>
             </a:r>
           </a:p>
           <a:p>
@@ -9610,7 +9613,7 @@
             <a:pPr lvl="0"/>
             <a:r>
               <a:rPr lang="en-US" sz="1800"/>
-              <a:t>Veracity - Software Engineering AI Paired Proving</a:t>
+              <a:t>Rusticate and Veracity - Software Engineering AI Paired Proving</a:t>
             </a:r>
           </a:p>
           <a:p>
@@ -9631,7 +9634,7 @@
             <a:pPr lvl="0"/>
             <a:r>
               <a:rPr lang="en-US" sz="1800"/>
-              <a:t>How bad is our computer security?</a:t>
+              <a:t>How Bad is Our Computer Security?</a:t>
             </a:r>
           </a:p>
           <a:p>
@@ -10170,7 +10173,7 @@
             <a:pPr lvl="0"/>
             <a:r>
               <a:rPr lang="en-US" sz="1800"/>
-              <a:t>The follow on tool for APAS-VERUS is Veracity, a suite of 22+ tools for analyzing, reviewing, and fixing Verus codebases.</a:t>
+              <a:t>Then Veracity, a suite of 22+ tools for analyzing, reviewing, and fixing Verus codebases.</a:t>
             </a:r>
           </a:p>
           <a:p>
@@ -10212,7 +10215,7 @@
             <a:pPr lvl="1"/>
             <a:r>
               <a:rPr lang="en-US" sz="1800"/>
-              <a:t>chapter-cleanliness-status (clean vs. holed chapter summary vs blocked by),</a:t>
+              <a:t>chapter-cleanliness-status</a:t>
             </a:r>
           </a:p>
           <a:p>
@@ -10947,14 +10950,7 @@
             <a:pPr lvl="0"/>
             <a:r>
               <a:rPr lang="en-US" sz="1800"/>
-              <a:t>Although APAS-AI and APAS-VERUS were developed without a formal SE process</a:t>
-            </a:r>
-          </a:p>
-          <a:p>
-            <a:pPr lvl="0"/>
-            <a:r>
-              <a:rPr lang="en-US" sz="1800"/>
-              <a:t>I eventually settled into a style and taught it to my AIs</a:t>
+              <a:t>I eventually settled into a semi-formal SE style and taught it to my AIs</a:t>
             </a:r>
           </a:p>
           <a:p>
@@ -11650,7 +11646,7 @@
                       </a:pPr>
                       <a:r>
                         <a:rPr/>
-                        <a:t>$ to produce specs, contracts, and proofs</a:t>
+                        <a:t>$ to produce specs and proofs</a:t>
                       </a:r>
                     </a:p>
                   </a:txBody>
@@ -14155,7 +14151,7 @@
             </a:pPr>
             <a:r>
               <a:rPr lang="en-US" sz="1800"/>
-              <a:t>Formatting - rust formatting has been adopted in Verus. It is very low density. I built a minimizing formatter to cut down on my working memory load while reviewing. F* is much tighter.</a:t>
+              <a:t>Formatting - rust formatting has been adopted in Verus. It is very low density.</a:t>
             </a:r>
           </a:p>
         </p:txBody>
@@ -15125,7 +15121,7 @@
             </a:r>
             <a:r>
               <a:rPr lang="en-US" sz="1800" b="1"/>
-              <a:t>HACL*/EverCrypt</a:t>
+              <a:t>HACL*</a:t>
             </a:r>
           </a:p>
           <a:p>
@@ -15159,7 +15155,7 @@
             </a:r>
             <a:r>
               <a:rPr lang="en-US" sz="1800"/>
-              <a:t> · Asterinas OSTD/OSDK · Linux net/ · </a:t>
+              <a:t> · Asterinas · Linux net/ · </a:t>
             </a:r>
             <a:r>
               <a:rPr lang="en-US" sz="1800" b="1"/>
@@ -15174,7 +15170,7 @@
             </a:r>
             <a:r>
               <a:rPr lang="en-US" sz="1800"/>
-              <a:t> — Linux drivers/base · </a:t>
+              <a:t> — Linux drivers · </a:t>
             </a:r>
             <a:r>
               <a:rPr lang="en-US" sz="1800" b="1"/>
@@ -15205,14 +15201,14 @@
             </a:r>
             <a:r>
               <a:rPr lang="en-US" sz="1800"/>
-              <a:t> — Unbound · chrony · BusyBox · Suricata · nginx · Redis · SQLite · NGINX Unit</a:t>
+              <a:t> — Unbound · chrony · BusyBox · Suricata · nginx · Redis · SQLite</a:t>
             </a:r>
           </a:p>
           <a:p>
             <a:pPr lvl="0"/>
             <a:r>
               <a:rPr lang="en-US" sz="1800" b="1"/>
-              <a:t>Distributed &amp; POP</a:t>
+              <a:t>Distributed</a:t>
             </a:r>
             <a:r>
               <a:rPr lang="en-US" sz="1800"/>
@@ -15232,7 +15228,18 @@
             </a:r>
             <a:r>
               <a:rPr lang="en-US" sz="1800"/>
-              <a:t> · FoundationDB · git · </a:t>
+              <a:t> · FoundationDB ·</a:t>
+            </a:r>
+          </a:p>
+          <a:p>
+            <a:pPr lvl="0"/>
+            <a:r>
+              <a:rPr lang="en-US" sz="1800" b="1"/>
+              <a:t>POP </a:t>
+            </a:r>
+            <a:r>
+              <a:rPr lang="en-US" sz="1800"/>
+              <a:t> - </a:t>
             </a:r>
             <a:r>
               <a:rPr lang="en-US" sz="1800" b="1"/>
@@ -16140,7 +16147,7 @@
             </a:pPr>
             <a:r>
               <a:rPr lang="en-US" sz="3200"/>
-              <a:t>20,570 KLOC · $90.9M · 3.0% example proven today</a:t>
+              <a:t>Cost of Proving ‘Everything’ You Need for Security</a:t>
             </a:r>
           </a:p>
         </p:txBody>
@@ -16167,34 +16174,39 @@
             </a:r>
           </a:p>
           <a:p>
-            <a:pPr lvl="0" indent="0" marL="0">
-              <a:buNone/>
-            </a:pPr>
-            <a:r>
-              <a:rPr lang="en-US" sz="1800"/>
-              <a:t>Estimated cost of Total KLOC | $41,140,000 |</a:t>
-            </a:r>
-            <a:br/>
-            <a:r>
-              <a:rPr lang="en-US" sz="1800"/>
-              <a:t>Estimated cost of Total Proven KLOC | $49,779,400 |</a:t>
-            </a:r>
-            <a:br/>
+            <a:pPr lvl="0"/>
+            <a:r>
+              <a:rPr lang="en-US" sz="1800"/>
+              <a:t>20,570 KLOC · $90.9M · 3.0% example proven today</a:t>
+            </a:r>
+          </a:p>
+          <a:p>
+            <a:pPr lvl="0"/>
+            <a:r>
+              <a:rPr lang="en-US" sz="1800"/>
+              <a:t>Estimated cost of Total KLOC - $41,140,000</a:t>
+            </a:r>
+          </a:p>
+          <a:p>
+            <a:pPr lvl="0"/>
+            <a:r>
+              <a:rPr lang="en-US" sz="1800"/>
+              <a:t>Estimated cost of Total Proven KLOC - $49,779,400</a:t>
+            </a:r>
+          </a:p>
+          <a:p>
+            <a:pPr lvl="0"/>
             <a:r>
               <a:rPr lang="en-US" sz="1800" b="1"/>
               <a:t>Estimated Total Cost</a:t>
             </a:r>
             <a:r>
               <a:rPr lang="en-US" sz="1800"/>
-              <a:t> | </a:t>
+              <a:t> - </a:t>
             </a:r>
             <a:r>
               <a:rPr lang="en-US" sz="1800" b="1"/>
               <a:t>$90,919,400</a:t>
-            </a:r>
-            <a:r>
-              <a:rPr lang="en-US" sz="1800"/>
-              <a:t> |</a:t>
             </a:r>
           </a:p>
         </p:txBody>
@@ -16299,14 +16311,14 @@
             <a:pPr lvl="0"/>
             <a:r>
               <a:rPr lang="en-US" sz="1800"/>
-              <a:t>Clear mutability.</a:t>
-            </a:r>
-          </a:p>
-          <a:p>
-            <a:pPr lvl="0"/>
-            <a:r>
-              <a:rPr lang="en-US" sz="1800"/>
-              <a:t>Slicing! with ownership.</a:t>
+              <a:t>Clear mutability, algebraic data types.</a:t>
+            </a:r>
+          </a:p>
+          <a:p>
+            <a:pPr lvl="0"/>
+            <a:r>
+              <a:rPr lang="en-US" sz="1800"/>
+              <a:t>Slicing! with ownership and borrow.</a:t>
             </a:r>
           </a:p>
           <a:p>
@@ -16405,6 +16417,13 @@
             <a:r>
               <a:rPr lang="en-US" sz="1800"/>
               <a:t>Will AIs just brute force the security problems?</a:t>
+            </a:r>
+          </a:p>
+          <a:p>
+            <a:pPr lvl="0"/>
+            <a:r>
+              <a:rPr lang="en-US" sz="1800"/>
+              <a:t>Programmers: will they accept proof?</a:t>
             </a:r>
           </a:p>
           <a:p>

</xml_diff>